<commit_message>
fix(scientific-reconciliation): reconcile forecast metrics, benchmark tables, presentation slides, and create final submission audit
</commit_message>
<xml_diff>
--- a/presentation/AEGIS_DATANOVA_2026.pptx
+++ b/presentation/AEGIS_DATANOVA_2026.pptx
@@ -3299,7 +3299,7 @@
               </a:defRPr>
             </a:pPr>
             <a:r>
-              <a:t>DATANOVA 2026 Submission  •  Milestone 4 Final Release  •  78 Passing Tests  •  Zero Fabricated Metrics</a:t>
+              <a:t>DATANOVA 2026 Submission  •  Milestone 4 Final Release  •  79 Passing Tests  •  Audited &amp; Reconciled Metrics</a:t>
             </a:r>
           </a:p>
         </p:txBody>
@@ -3515,10 +3515,9 @@
               <a:t>Production Rollout Roadmap</a:t>
             </a:r>
           </a:p>
-          <a:p/>
-          <a:p>
-            <a:pPr>
-              <a:defRPr sz="1100">
+          <a:p>
+            <a:pPr>
+              <a:defRPr sz="1100" b="0">
                 <a:solidFill>
                   <a:srgbClr val="172B46"/>
                 </a:solidFill>
@@ -3530,7 +3529,7 @@
           </a:p>
           <a:p>
             <a:pPr>
-              <a:defRPr sz="1100">
+              <a:defRPr sz="1100" b="0">
                 <a:solidFill>
                   <a:srgbClr val="172B46"/>
                 </a:solidFill>
@@ -3542,7 +3541,7 @@
           </a:p>
           <a:p>
             <a:pPr>
-              <a:defRPr sz="1100">
+              <a:defRPr sz="1100" b="0">
                 <a:solidFill>
                   <a:srgbClr val="172B46"/>
                 </a:solidFill>
@@ -3554,7 +3553,7 @@
           </a:p>
           <a:p>
             <a:pPr>
-              <a:defRPr sz="1100">
+              <a:defRPr sz="1100" b="0">
                 <a:solidFill>
                   <a:srgbClr val="172B46"/>
                 </a:solidFill>
@@ -3644,34 +3643,33 @@
               <a:t>Quantified Healthcare Impact</a:t>
             </a:r>
           </a:p>
-          <a:p/>
-          <a:p>
-            <a:pPr>
-              <a:defRPr sz="1100">
+          <a:p>
+            <a:pPr>
+              <a:defRPr sz="1100" b="0">
                 <a:solidFill>
                   <a:srgbClr val="172B46"/>
                 </a:solidFill>
               </a:defRPr>
             </a:pPr>
             <a:r>
-              <a:t>• 22% Reduction in Preventable Shortages: Level 1 Trauma protection ensures critical surgical consumables remain stocked during regional surges.</a:t>
-            </a:r>
-          </a:p>
-          <a:p>
-            <a:pPr>
-              <a:defRPr sz="1100">
+              <a:t>• 49% Reduction in Preventable Shortages: Stochastic MILP slashes mean unmet demand from 1,862 units to 937.9 units on the common benchmark.</a:t>
+            </a:r>
+          </a:p>
+          <a:p>
+            <a:pPr>
+              <a:defRPr sz="1100" b="0">
                 <a:solidFill>
                   <a:srgbClr val="172B46"/>
                 </a:solidFill>
               </a:defRPr>
             </a:pPr>
             <a:r>
-              <a:t>• 19.1% Reduction in Operating Costs: High route consolidation eliminates redundant dispatches, saving ~$50k per regional restocking cycle.</a:t>
-            </a:r>
-          </a:p>
-          <a:p>
-            <a:pPr>
-              <a:defRPr sz="1100">
+              <a:t>• 38%–40% Modeled Cost Reduction: Multi-scenario hedging eliminates $170k–$190k in emergency clinical penalties while optimizing physical fleet routing.</a:t>
+            </a:r>
+          </a:p>
+          <a:p>
+            <a:pPr>
+              <a:defRPr sz="1100" b="0">
                 <a:solidFill>
                   <a:srgbClr val="172B46"/>
                 </a:solidFill>
@@ -3894,41 +3892,40 @@
               <a:t>1. Operational Vulnerability</a:t>
             </a:r>
           </a:p>
-          <a:p/>
-          <a:p>
-            <a:pPr>
-              <a:defRPr sz="1200">
+          <a:p>
+            <a:pPr>
+              <a:defRPr sz="1100" b="0">
                 <a:solidFill>
                   <a:srgbClr val="172B46"/>
                 </a:solidFill>
               </a:defRPr>
             </a:pPr>
             <a:r>
-              <a:t>• Modern hospitals rely on uninterrupted flows of consumable PPE, biocidal disinfectants, and biohazard supplies.</a:t>
-            </a:r>
-          </a:p>
-          <a:p>
-            <a:pPr>
-              <a:defRPr sz="1200">
+              <a:t>• Hospitals rely on uninterrupted flows of PPE, disinfectants, and sterile supplies.</a:t>
+            </a:r>
+          </a:p>
+          <a:p>
+            <a:pPr>
+              <a:defRPr sz="1100" b="0">
                 <a:solidFill>
                   <a:srgbClr val="172B46"/>
                 </a:solidFill>
               </a:defRPr>
             </a:pPr>
             <a:r>
-              <a:t>• Stockouts halt elective surgeries, expose clinical staff to pathogens, and trigger emergency ad-hoc courier fees.</a:t>
-            </a:r>
-          </a:p>
-          <a:p>
-            <a:pPr>
-              <a:defRPr sz="1200">
+              <a:t>• Stockouts halt elective surgeries and trigger emergency ad-hoc courier fees.</a:t>
+            </a:r>
+          </a:p>
+          <a:p>
+            <a:pPr>
+              <a:defRPr sz="1100" b="0">
                 <a:solidFill>
                   <a:srgbClr val="172B46"/>
                 </a:solidFill>
               </a:defRPr>
             </a:pPr>
             <a:r>
-              <a:t>• Demand is non-stationary, exhibiting dual weekly rhythms, Poisson emergency surges, and seasonal waves.</a:t>
+              <a:t>• Demand is non-stationary, exhibiting dual rhythms and Poisson emergency surges.</a:t>
             </a:r>
           </a:p>
         </p:txBody>
@@ -4011,41 +4008,40 @@
               <a:t>2. The Supply Chain Trilemma</a:t>
             </a:r>
           </a:p>
-          <a:p/>
-          <a:p>
-            <a:pPr>
-              <a:defRPr sz="1200">
+          <a:p>
+            <a:pPr>
+              <a:defRPr sz="1100" b="0">
                 <a:solidFill>
                   <a:srgbClr val="172B46"/>
                 </a:solidFill>
               </a:defRPr>
             </a:pPr>
             <a:r>
-              <a:t>• Clinical Severity vs. Budget: Trauma centers face 3x shortage penalty multipliers over specialty clinics.</a:t>
-            </a:r>
-          </a:p>
-          <a:p>
-            <a:pPr>
-              <a:defRPr sz="1200">
+              <a:t>• Clinical Severity vs. Budget: Trauma centers face 3x shortage penalty multipliers.</a:t>
+            </a:r>
+          </a:p>
+          <a:p>
+            <a:pPr>
+              <a:defRPr sz="1100" b="0">
                 <a:solidFill>
                   <a:srgbClr val="172B46"/>
                 </a:solidFill>
               </a:defRPr>
             </a:pPr>
             <a:r>
-              <a:t>• Routing Economics vs. Responsiveness: Fixed route activation costs ($150 + $1.20/km) demand load consolidation.</a:t>
-            </a:r>
-          </a:p>
-          <a:p>
-            <a:pPr>
-              <a:defRPr sz="1200">
+              <a:t>• Routing Economics vs. Responsiveness: Fixed route fees ($150 + $1.20/km) demand consolidation.</a:t>
+            </a:r>
+          </a:p>
+          <a:p>
+            <a:pPr>
+              <a:defRPr sz="1100" b="0">
                 <a:solidFill>
                   <a:srgbClr val="172B46"/>
                 </a:solidFill>
               </a:defRPr>
             </a:pPr>
             <a:r>
-              <a:t>• Fairness vs. Efficiency: Pure proportional allocation starves high-severity centers, while greedy allocation abandons rural clinics.</a:t>
+              <a:t>• Fairness vs. Efficiency: Proportional allocation starves trauma centers; greedy allocation abandons rural clinics.</a:t>
             </a:r>
           </a:p>
         </p:txBody>
@@ -4128,22 +4124,21 @@
               <a:t>3. The AEGIS Innovation</a:t>
             </a:r>
           </a:p>
-          <a:p/>
-          <a:p>
-            <a:pPr>
-              <a:defRPr sz="1200">
+          <a:p>
+            <a:pPr>
+              <a:defRPr sz="1100" b="0">
                 <a:solidFill>
                   <a:srgbClr val="172B46"/>
                 </a:solidFill>
               </a:defRPr>
             </a:pPr>
             <a:r>
-              <a:t>• Unified Decision Loop: Seamlessly links quantile demand forecasts into exact operations research solvers.</a:t>
-            </a:r>
-          </a:p>
-          <a:p>
-            <a:pPr>
-              <a:defRPr sz="1200">
+              <a:t>• Unified Decision Loop: Seamlessly links quantile demand forecasts into exact MILP solvers.</a:t>
+            </a:r>
+          </a:p>
+          <a:p>
+            <a:pPr>
+              <a:defRPr sz="1100" b="0">
                 <a:solidFill>
                   <a:srgbClr val="172B46"/>
                 </a:solidFill>
@@ -4155,14 +4150,14 @@
           </a:p>
           <a:p>
             <a:pPr>
-              <a:defRPr sz="1200">
+              <a:defRPr sz="1100" b="0">
                 <a:solidFill>
                   <a:srgbClr val="172B46"/>
                 </a:solidFill>
               </a:defRPr>
             </a:pPr>
             <a:r>
-              <a:t>• Explainable &amp; Grounded: TreeSHAP for predictions, Decision Explainer for allocations, Grounded GenAI for operations directors.</a:t>
+              <a:t>• Explainable &amp; Grounded: TreeSHAP for forecasts, Decision Explainer for allocations, Grounded GenAI for directors.</a:t>
             </a:r>
           </a:p>
         </p:txBody>
@@ -4378,65 +4373,64 @@
               <a:t>Physically Grounded Synthetic Topology</a:t>
             </a:r>
           </a:p>
-          <a:p/>
-          <a:p>
-            <a:pPr>
-              <a:defRPr sz="1100">
+          <a:p>
+            <a:pPr>
+              <a:defRPr sz="1100" b="0">
                 <a:solidFill>
                   <a:srgbClr val="172B46"/>
                 </a:solidFill>
               </a:defRPr>
             </a:pPr>
             <a:r>
-              <a:t>• 20 Simulated Hospitals: 4 operational tiers (Level 1 Trauma, Regional Referral, Community, Specialty Clinic) with 90 to 850 beds.</a:t>
-            </a:r>
-          </a:p>
-          <a:p>
-            <a:pPr>
-              <a:defRPr sz="1100">
+              <a:t>• 20 Simulated Hospitals across 4 tiers (Level 1 Trauma to Specialty Clinics) with 90–850 beds.</a:t>
+            </a:r>
+          </a:p>
+          <a:p>
+            <a:pPr>
+              <a:defRPr sz="1100" b="0">
                 <a:solidFill>
                   <a:srgbClr val="172B46"/>
                 </a:solidFill>
               </a:defRPr>
             </a:pPr>
             <a:r>
-              <a:t>• 3 Regional Depots: Central Logistics Center (50%), Northern Depot (25%), Southern Depot (25%).</a:t>
-            </a:r>
-          </a:p>
-          <a:p>
-            <a:pPr>
-              <a:defRPr sz="1100">
+              <a:t>• 3 Fulfillment Depots: Central Logistics Depot (50%), Northern Hub (25%), Southern Hub (25%).</a:t>
+            </a:r>
+          </a:p>
+          <a:p>
+            <a:pPr>
+              <a:defRPr sz="1100" b="0">
                 <a:solidFill>
                   <a:srgbClr val="172B46"/>
                 </a:solidFill>
               </a:defRPr>
             </a:pPr>
             <a:r>
-              <a:t>• 3 Product Categories: PPE, Sanitation, and Medical Utility supplies across 365 daily observations (21,900 panel rows).</a:t>
-            </a:r>
-          </a:p>
-          <a:p>
-            <a:pPr>
-              <a:defRPr sz="1100">
+              <a:t>• 3 Product Categories: PPE, Sanitation, and Medical Utility across 365 daily observations (21,900 rows).</a:t>
+            </a:r>
+          </a:p>
+          <a:p>
+            <a:pPr>
+              <a:defRPr sz="1100" b="0">
                 <a:solidFill>
                   <a:srgbClr val="172B46"/>
                 </a:solidFill>
               </a:defRPr>
             </a:pPr>
             <a:r>
-              <a:t>• Synthetic Coordinates: Cartesian 2D grid with 1.25 road circuity factor to compute genuine Euclidean road transport distances.</a:t>
-            </a:r>
-          </a:p>
-          <a:p>
-            <a:pPr>
-              <a:defRPr sz="1100">
+              <a:t>• Synthetic Coordinates: Cartesian 2D grid with 1.25 circuity factor for road transit distances.</a:t>
+            </a:r>
+          </a:p>
+          <a:p>
+            <a:pPr>
+              <a:defRPr sz="1100" b="0">
                 <a:solidFill>
                   <a:srgbClr val="172B46"/>
                 </a:solidFill>
               </a:defRPr>
             </a:pPr>
             <a:r>
-              <a:t>• Provable Reproducibility: Seed=42, companion manifest.json, and cryptographic SHA-256 integrity hashes.</a:t>
+              <a:t>• Provable Reproducibility: Deterministic seed=42, manifest.json, and SHA-256 cryptographic hashes.</a:t>
             </a:r>
           </a:p>
         </p:txBody>
@@ -4519,10 +4513,9 @@
               <a:t>Strict Anti-Leakage Protocol</a:t>
             </a:r>
           </a:p>
-          <a:p/>
-          <a:p>
-            <a:pPr>
-              <a:defRPr sz="1100">
+          <a:p>
+            <a:pPr>
+              <a:defRPr sz="1100" b="0">
                 <a:solidFill>
                   <a:srgbClr val="172B46"/>
                 </a:solidFill>
@@ -4534,7 +4527,7 @@
           </a:p>
           <a:p>
             <a:pPr>
-              <a:defRPr sz="1000">
+              <a:defRPr sz="1000" b="0">
                 <a:solidFill>
                   <a:srgbClr val="64748B"/>
                 </a:solidFill>
@@ -4546,19 +4539,19 @@
           </a:p>
           <a:p>
             <a:pPr>
-              <a:defRPr sz="1000">
+              <a:defRPr sz="1000" b="0">
                 <a:solidFill>
                   <a:srgbClr val="64748B"/>
                 </a:solidFill>
               </a:defRPr>
             </a:pPr>
             <a:r>
-              <a:t>   - Development / Val Set: Days 261–310 (~50 days, hyperparameter tuning &amp; conformal calibration)</a:t>
-            </a:r>
-          </a:p>
-          <a:p>
-            <a:pPr>
-              <a:defRPr sz="1000">
+              <a:t>   - Development / Val Set: Days 261–310 (~50 days for tuning and calibration)</a:t>
+            </a:r>
+          </a:p>
+          <a:p>
+            <a:pPr>
+              <a:defRPr sz="1000" b="0">
                 <a:solidFill>
                   <a:srgbClr val="64748B"/>
                 </a:solidFill>
@@ -4570,26 +4563,26 @@
           </a:p>
           <a:p>
             <a:pPr>
-              <a:defRPr sz="1100">
+              <a:defRPr sz="1100" b="0">
                 <a:solidFill>
                   <a:srgbClr val="172B46"/>
                 </a:solidFill>
               </a:defRPr>
             </a:pPr>
             <a:r>
-              <a:t>• Shifted Rolling Lags: All rolling statistics apply shift(1) ensuring observation t is excluded from feature vectors for time t.</a:t>
-            </a:r>
-          </a:p>
-          <a:p>
-            <a:pPr>
-              <a:defRPr sz="1100">
+              <a:t>• Shifted Rolling Lags: All rolling statistics apply shift(1) to guarantee zero current-day target leakage.</a:t>
+            </a:r>
+          </a:p>
+          <a:p>
+            <a:pPr>
+              <a:defRPr sz="1100" b="0">
                 <a:solidFill>
                   <a:srgbClr val="172B46"/>
                 </a:solidFill>
               </a:defRPr>
             </a:pPr>
             <a:r>
-              <a:t>• Imputation Directionality: Telemetry dropouts use forward-fill (ffill); back-fill and global statistics are forbidden.</a:t>
+              <a:t>• Imputation Directionality: Telemetry dropouts use forward-fill (ffill); back-fill is forbidden.</a:t>
             </a:r>
           </a:p>
         </p:txBody>
@@ -4906,7 +4899,7 @@
               </a:defRPr>
             </a:pPr>
             <a:r>
-              <a:t>Quantile GBDT (reg:quantileerror) producing point forecasts alongside 10th and 90th percentile bounds. Validated test WAPE: 14.62%, empirical interval coverage: 82.3% at nominal 80%.</a:t>
+              <a:t>Quantile GBDT producing point forecasts alongside 10th and 90th percentile bounds. Validated test WAPE: 14.62% (MAE: 54.240 vs Seasonal-Naive: 113.339; -52.1% error reduction). Empirical 80% interval coverage: 84.64% on held-out test data.</a:t>
             </a:r>
           </a:p>
         </p:txBody>
@@ -5306,10 +5299,9 @@
               <a:t>Mathematical Formulation</a:t>
             </a:r>
           </a:p>
-          <a:p/>
-          <a:p>
-            <a:pPr>
-              <a:defRPr b="1" sz="1100">
+          <a:p>
+            <a:pPr>
+              <a:defRPr sz="1100" b="1">
                 <a:solidFill>
                   <a:srgbClr val="172B46"/>
                 </a:solidFill>
@@ -5321,7 +5313,7 @@
           </a:p>
           <a:p>
             <a:pPr>
-              <a:defRPr sz="1000">
+              <a:defRPr sz="1000" b="0">
                 <a:solidFill>
                   <a:srgbClr val="64748B"/>
                 </a:solidFill>
@@ -5333,7 +5325,7 @@
           </a:p>
           <a:p>
             <a:pPr>
-              <a:defRPr sz="1000">
+              <a:defRPr sz="1000" b="0">
                 <a:solidFill>
                   <a:srgbClr val="64748B"/>
                 </a:solidFill>
@@ -5345,7 +5337,7 @@
           </a:p>
           <a:p>
             <a:pPr>
-              <a:defRPr sz="1000">
+              <a:defRPr sz="1000" b="0">
                 <a:solidFill>
                   <a:srgbClr val="64748B"/>
                 </a:solidFill>
@@ -5357,7 +5349,7 @@
           </a:p>
           <a:p>
             <a:pPr>
-              <a:defRPr sz="1000">
+              <a:defRPr sz="1000" b="0">
                 <a:solidFill>
                   <a:srgbClr val="64748B"/>
                 </a:solidFill>
@@ -5367,10 +5359,9 @@
               <a:t>• s(h,c,k) &gt;= 0: Continuous unmet demand recourse shortage.</a:t>
             </a:r>
           </a:p>
-          <a:p/>
-          <a:p>
-            <a:pPr>
-              <a:defRPr b="1" sz="1100">
+          <a:p>
+            <a:pPr>
+              <a:defRPr sz="1100" b="1">
                 <a:solidFill>
                   <a:srgbClr val="172B46"/>
                 </a:solidFill>
@@ -5382,7 +5373,7 @@
           </a:p>
           <a:p>
             <a:pPr>
-              <a:defRPr sz="1000">
+              <a:defRPr sz="1000" b="0">
                 <a:solidFill>
                   <a:srgbClr val="2367A3"/>
                 </a:solidFill>
@@ -5394,7 +5385,7 @@
           </a:p>
           <a:p>
             <a:pPr>
-              <a:defRPr sz="1000">
+              <a:defRPr sz="1000" b="0">
                 <a:solidFill>
                   <a:srgbClr val="172B46"/>
                 </a:solidFill>
@@ -5402,6 +5393,18 @@
             </a:pPr>
             <a:r>
               <a:t>Where pi_short reflects clinical triage weights (Level 1 Trauma = 3.0x, Regional = 2.0x, Community = 1.2x, Specialty = 1.0x).</a:t>
+            </a:r>
+          </a:p>
+          <a:p>
+            <a:pPr>
+              <a:defRPr sz="1000" b="1">
+                <a:solidFill>
+                  <a:srgbClr val="C78B31"/>
+                </a:solidFill>
+              </a:defRPr>
+            </a:pPr>
+            <a:r>
+              <a:t>• Explicit Cost Distinction: Physical cash freight (distance, vehicle trips, route fees) is ~$34k–$45k. Modeled shortage penalty ($150–$450/unit) reflects patient triage risk.</a:t>
             </a:r>
           </a:p>
         </p:txBody>
@@ -5484,10 +5487,9 @@
               <a:t>Physical Constraints &amp; Relaxation Analysis</a:t>
             </a:r>
           </a:p>
-          <a:p/>
-          <a:p>
-            <a:pPr>
-              <a:defRPr b="1" sz="1100">
+          <a:p>
+            <a:pPr>
+              <a:defRPr sz="1100" b="1">
                 <a:solidFill>
                   <a:srgbClr val="172B46"/>
                 </a:solidFill>
@@ -5499,7 +5501,7 @@
           </a:p>
           <a:p>
             <a:pPr>
-              <a:defRPr sz="1000">
+              <a:defRPr sz="1000" b="0">
                 <a:solidFill>
                   <a:srgbClr val="64748B"/>
                 </a:solidFill>
@@ -5511,7 +5513,7 @@
           </a:p>
           <a:p>
             <a:pPr>
-              <a:defRPr sz="1000">
+              <a:defRPr sz="1000" b="0">
                 <a:solidFill>
                   <a:srgbClr val="64748B"/>
                 </a:solidFill>
@@ -5523,7 +5525,7 @@
           </a:p>
           <a:p>
             <a:pPr>
-              <a:defRPr sz="1000">
+              <a:defRPr sz="1000" b="0">
                 <a:solidFill>
                   <a:srgbClr val="64748B"/>
                 </a:solidFill>
@@ -5535,7 +5537,7 @@
           </a:p>
           <a:p>
             <a:pPr>
-              <a:defRPr sz="1000">
+              <a:defRPr sz="1000" b="0">
                 <a:solidFill>
                   <a:srgbClr val="64748B"/>
                 </a:solidFill>
@@ -5545,10 +5547,9 @@
               <a:t>4. Minimum Service Coverage (Fairness): sum_w x &gt;= alpha_min * d</a:t>
             </a:r>
           </a:p>
-          <a:p/>
-          <a:p>
-            <a:pPr>
-              <a:defRPr b="1" sz="1100">
+          <a:p>
+            <a:pPr>
+              <a:defRPr sz="1100" b="1">
                 <a:solidFill>
                   <a:srgbClr val="C78B31"/>
                 </a:solidFill>
@@ -5560,7 +5561,7 @@
           </a:p>
           <a:p>
             <a:pPr>
-              <a:defRPr sz="1000">
+              <a:defRPr sz="1000" b="0">
                 <a:solidFill>
                   <a:srgbClr val="172B46"/>
                 </a:solidFill>
@@ -5783,10 +5784,9 @@
               <a:t>1. TreeSHAP (ML Forecast)</a:t>
             </a:r>
           </a:p>
-          <a:p/>
-          <a:p>
-            <a:pPr>
-              <a:defRPr sz="1100">
+          <a:p>
+            <a:pPr>
+              <a:defRPr sz="1100" b="0">
                 <a:solidFill>
                   <a:srgbClr val="172B46"/>
                 </a:solidFill>
@@ -5798,7 +5798,7 @@
           </a:p>
           <a:p>
             <a:pPr>
-              <a:defRPr sz="1100">
+              <a:defRPr sz="1100" b="0">
                 <a:solidFill>
                   <a:srgbClr val="172B46"/>
                 </a:solidFill>
@@ -5810,7 +5810,7 @@
           </a:p>
           <a:p>
             <a:pPr>
-              <a:defRPr sz="1100">
+              <a:defRPr sz="1100" b="0">
                 <a:solidFill>
                   <a:srgbClr val="172B46"/>
                 </a:solidFill>
@@ -5822,7 +5822,7 @@
           </a:p>
           <a:p>
             <a:pPr>
-              <a:defRPr sz="1100">
+              <a:defRPr sz="1100" b="0">
                 <a:solidFill>
                   <a:srgbClr val="172B46"/>
                 </a:solidFill>
@@ -5912,10 +5912,9 @@
               <a:t>2. Decision Explainer (OR)</a:t>
             </a:r>
           </a:p>
-          <a:p/>
-          <a:p>
-            <a:pPr>
-              <a:defRPr sz="1100">
+          <a:p>
+            <a:pPr>
+              <a:defRPr sz="1100" b="0">
                 <a:solidFill>
                   <a:srgbClr val="172B46"/>
                 </a:solidFill>
@@ -5927,7 +5926,7 @@
           </a:p>
           <a:p>
             <a:pPr>
-              <a:defRPr sz="1100">
+              <a:defRPr sz="1100" b="0">
                 <a:solidFill>
                   <a:srgbClr val="172B46"/>
                 </a:solidFill>
@@ -5939,7 +5938,7 @@
           </a:p>
           <a:p>
             <a:pPr>
-              <a:defRPr sz="1100">
+              <a:defRPr sz="1100" b="0">
                 <a:solidFill>
                   <a:srgbClr val="172B46"/>
                 </a:solidFill>
@@ -6029,10 +6028,9 @@
               <a:t>3. Grounded GenAI Layer</a:t>
             </a:r>
           </a:p>
-          <a:p/>
-          <a:p>
-            <a:pPr>
-              <a:defRPr sz="1100">
+          <a:p>
+            <a:pPr>
+              <a:defRPr sz="1100" b="0">
                 <a:solidFill>
                   <a:srgbClr val="172B46"/>
                 </a:solidFill>
@@ -6044,7 +6042,7 @@
           </a:p>
           <a:p>
             <a:pPr>
-              <a:defRPr sz="1100">
+              <a:defRPr sz="1100" b="0">
                 <a:solidFill>
                   <a:srgbClr val="172B46"/>
                 </a:solidFill>
@@ -6056,7 +6054,7 @@
           </a:p>
           <a:p>
             <a:pPr>
-              <a:defRPr sz="1100">
+              <a:defRPr sz="1100" b="0">
                 <a:solidFill>
                   <a:srgbClr val="172B46"/>
                 </a:solidFill>
@@ -6068,7 +6066,7 @@
           </a:p>
           <a:p>
             <a:pPr>
-              <a:defRPr sz="1100">
+              <a:defRPr sz="1100" b="0">
                 <a:solidFill>
                   <a:srgbClr val="172B46"/>
                 </a:solidFill>
@@ -6276,7 +6274,7 @@
                         </a:defRPr>
                       </a:pPr>
                       <a:r>
-                        <a:t>Feasible Instances</a:t>
+                        <a:t>Feasibility Rate (30 runs)</a:t>
                       </a:r>
                     </a:p>
                   </a:txBody>
@@ -6299,7 +6297,7 @@
                         </a:defRPr>
                       </a:pPr>
                       <a:r>
-                        <a:t>Mean Fill Rate</a:t>
+                        <a:t>Mean Fill Rate (N=16)</a:t>
                       </a:r>
                     </a:p>
                   </a:txBody>
@@ -6322,7 +6320,7 @@
                         </a:defRPr>
                       </a:pPr>
                       <a:r>
-                        <a:t>Mean Total Cost ($)</a:t>
+                        <a:t>Cash Freight Cost</a:t>
                       </a:r>
                     </a:p>
                   </a:txBody>
@@ -6345,7 +6343,7 @@
                         </a:defRPr>
                       </a:pPr>
                       <a:r>
-                        <a:t>Shortage Penalty ($)</a:t>
+                        <a:t>Shortage Penalty</a:t>
                       </a:r>
                     </a:p>
                   </a:txBody>
@@ -6368,7 +6366,7 @@
                         </a:defRPr>
                       </a:pPr>
                       <a:r>
-                        <a:t>Mean Solve Time</a:t>
+                        <a:t>Modeled Total Cost</a:t>
                       </a:r>
                     </a:p>
                   </a:txBody>
@@ -6393,7 +6391,7 @@
                         </a:defRPr>
                       </a:pPr>
                       <a:r>
-                        <a:t>Deterministic MILP (HiGHS)</a:t>
+                        <a:t>Two-Stage Stochastic MILP</a:t>
                       </a:r>
                     </a:p>
                   </a:txBody>
@@ -6416,7 +6414,7 @@
                         </a:defRPr>
                       </a:pPr>
                       <a:r>
-                        <a:t>21 / 25 (84%)</a:t>
+                        <a:t>25 / 30 (83.3%)</a:t>
                       </a:r>
                     </a:p>
                   </a:txBody>
@@ -6439,7 +6437,7 @@
                         </a:defRPr>
                       </a:pPr>
                       <a:r>
-                        <a:t>95.8%</a:t>
+                        <a:t>99.13%</a:t>
                       </a:r>
                     </a:p>
                   </a:txBody>
@@ -6462,7 +6460,7 @@
                         </a:defRPr>
                       </a:pPr>
                       <a:r>
-                        <a:t>$214,520</a:t>
+                        <a:t>$44,623</a:t>
                       </a:r>
                     </a:p>
                   </a:txBody>
@@ -6485,7 +6483,7 @@
                         </a:defRPr>
                       </a:pPr>
                       <a:r>
-                        <a:t>$14,200</a:t>
+                        <a:t>$233,435</a:t>
                       </a:r>
                     </a:p>
                   </a:txBody>
@@ -6508,7 +6506,7 @@
                         </a:defRPr>
                       </a:pPr>
                       <a:r>
-                        <a:t>0.42 s</a:t>
+                        <a:t>$278,058</a:t>
                       </a:r>
                     </a:p>
                   </a:txBody>
@@ -6533,7 +6531,7 @@
                         </a:defRPr>
                       </a:pPr>
                       <a:r>
-                        <a:t>Two-Stage Stochastic MILP</a:t>
+                        <a:t>Deterministic MILP (HiGHS)</a:t>
                       </a:r>
                     </a:p>
                   </a:txBody>
@@ -6556,7 +6554,7 @@
                         </a:defRPr>
                       </a:pPr>
                       <a:r>
-                        <a:t>18 / 25 (72%)</a:t>
+                        <a:t>21 / 30 (70.0%)*</a:t>
                       </a:r>
                     </a:p>
                   </a:txBody>
@@ -6579,7 +6577,7 @@
                         </a:defRPr>
                       </a:pPr>
                       <a:r>
-                        <a:t>95.6%</a:t>
+                        <a:t>96.95%</a:t>
                       </a:r>
                     </a:p>
                   </a:txBody>
@@ -6602,7 +6600,7 @@
                         </a:defRPr>
                       </a:pPr>
                       <a:r>
-                        <a:t>$218,140</a:t>
+                        <a:t>$33,732</a:t>
                       </a:r>
                     </a:p>
                   </a:txBody>
@@ -6625,7 +6623,7 @@
                         </a:defRPr>
                       </a:pPr>
                       <a:r>
-                        <a:t>$14,850</a:t>
+                        <a:t>$414,728</a:t>
                       </a:r>
                     </a:p>
                   </a:txBody>
@@ -6648,7 +6646,7 @@
                         </a:defRPr>
                       </a:pPr>
                       <a:r>
-                        <a:t>1.85 s</a:t>
+                        <a:t>$448,459</a:t>
                       </a:r>
                     </a:p>
                   </a:txBody>
@@ -6696,7 +6694,7 @@
                         </a:defRPr>
                       </a:pPr>
                       <a:r>
-                        <a:t>20 / 25 (80%)</a:t>
+                        <a:t>20 / 30 (66.7%)</a:t>
                       </a:r>
                     </a:p>
                   </a:txBody>
@@ -6719,7 +6717,7 @@
                         </a:defRPr>
                       </a:pPr>
                       <a:r>
-                        <a:t>91.2%</a:t>
+                        <a:t>96.78%</a:t>
                       </a:r>
                     </a:p>
                   </a:txBody>
@@ -6742,7 +6740,7 @@
                         </a:defRPr>
                       </a:pPr>
                       <a:r>
-                        <a:t>$264,800</a:t>
+                        <a:t>$38,410</a:t>
                       </a:r>
                     </a:p>
                   </a:txBody>
@@ -6765,7 +6763,7 @@
                         </a:defRPr>
                       </a:pPr>
                       <a:r>
-                        <a:t>$32,100</a:t>
+                        <a:t>$420,264</a:t>
                       </a:r>
                     </a:p>
                   </a:txBody>
@@ -6788,7 +6786,7 @@
                         </a:defRPr>
                       </a:pPr>
                       <a:r>
-                        <a:t>0.01 s</a:t>
+                        <a:t>$458,674</a:t>
                       </a:r>
                     </a:p>
                   </a:txBody>
@@ -6836,7 +6834,7 @@
                         </a:defRPr>
                       </a:pPr>
                       <a:r>
-                        <a:t>24 / 25 (96%)</a:t>
+                        <a:t>24 / 30 (80.0%)</a:t>
                       </a:r>
                     </a:p>
                   </a:txBody>
@@ -6859,7 +6857,7 @@
                         </a:defRPr>
                       </a:pPr>
                       <a:r>
-                        <a:t>88.4%</a:t>
+                        <a:t>95.79%</a:t>
                       </a:r>
                     </a:p>
                   </a:txBody>
@@ -6882,7 +6880,7 @@
                         </a:defRPr>
                       </a:pPr>
                       <a:r>
-                        <a:t>$295,400</a:t>
+                        <a:t>$37,783</a:t>
                       </a:r>
                     </a:p>
                   </a:txBody>
@@ -6905,7 +6903,7 @@
                         </a:defRPr>
                       </a:pPr>
                       <a:r>
-                        <a:t>$48,900</a:t>
+                        <a:t>$429,860</a:t>
                       </a:r>
                     </a:p>
                   </a:txBody>
@@ -6928,7 +6926,7 @@
                         </a:defRPr>
                       </a:pPr>
                       <a:r>
-                        <a:t>0.004 s</a:t>
+                        <a:t>$467,643</a:t>
                       </a:r>
                     </a:p>
                   </a:txBody>
@@ -7018,31 +7016,43 @@
               </a:defRPr>
             </a:pPr>
             <a:r>
-              <a:t>Key Verified Audit Insights (Milestone 2 Audit &amp; Repair):</a:t>
-            </a:r>
-          </a:p>
-          <a:p>
-            <a:pPr>
-              <a:defRPr sz="1100">
+              <a:t>Audited Benchmark Evidence (Common Feasible Subset N=16 Matched Scenarios):</a:t>
+            </a:r>
+          </a:p>
+          <a:p>
+            <a:pPr>
+              <a:defRPr sz="1100" b="0">
                 <a:solidFill>
                   <a:srgbClr val="172B46"/>
                 </a:solidFill>
               </a:defRPr>
             </a:pPr>
             <a:r>
-              <a:t>• Common-Feasible Subset (N=16 matched pairs): Deterministic MILP achieves identical service coverage while reducing total logistics cost by 19.1% relative to Greedy ($50,280 saved per dispatch) and 27.4% relative to Proportional.</a:t>
-            </a:r>
-          </a:p>
-          <a:p>
-            <a:pPr>
-              <a:defRPr sz="1100">
+              <a:t>• Stochastic MILP Dominance: Two-Stage Stochastic MILP cuts modeled total cost by -$170,401 (-38.0%) vs Deterministic MILP and -$189,585 (-40.5%) vs Proportional (p &lt; 0.0001, 95% bootstrap CI).</a:t>
+            </a:r>
+          </a:p>
+          <a:p>
+            <a:pPr>
+              <a:defRPr sz="1100" b="0">
                 <a:solidFill>
                   <a:srgbClr val="172B46"/>
                 </a:solidFill>
               </a:defRPr>
             </a:pPr>
             <a:r>
-              <a:t>• Integrality &amp; Feasibility Guarantee: Every evaluated allocation passes independent feasibility checks with zero warehouse inventory overdraw and strict adherence to vehicle capacity limits.</a:t>
+              <a:t>• Cash Freight vs Modeled Penalties: Stochastic MILP spends ~$6.8k–$10.8k more in physical freight consolidation to satisfy demand under upper-tail surges, eliminating over $180k in catastrophic hospital shortage penalties.</a:t>
+            </a:r>
+          </a:p>
+          <a:p>
+            <a:pPr>
+              <a:defRPr sz="1000" b="0">
+                <a:solidFill>
+                  <a:srgbClr val="64748B"/>
+                </a:solidFill>
+              </a:defRPr>
+            </a:pPr>
+            <a:r>
+              <a:t>• Note: Synthetic simulation across 30 instances (6 regimes). Modeled total costs reflect clinical triage penalties ($150–$450/unit); physical cash freight spend is $34k–$45k. *4 Det MILP runs had valid incumbents at time limit.</a:t>
             </a:r>
           </a:p>
         </p:txBody>
@@ -7509,10 +7519,9 @@
               <a:t>Responsible AI &amp; Governance Safeguards</a:t>
             </a:r>
           </a:p>
-          <a:p/>
-          <a:p>
-            <a:pPr>
-              <a:defRPr sz="1100">
+          <a:p>
+            <a:pPr>
+              <a:defRPr sz="1100" b="0">
                 <a:solidFill>
                   <a:srgbClr val="172B46"/>
                 </a:solidFill>
@@ -7524,7 +7533,7 @@
           </a:p>
           <a:p>
             <a:pPr>
-              <a:defRPr sz="1100">
+              <a:defRPr sz="1100" b="0">
                 <a:solidFill>
                   <a:srgbClr val="172B46"/>
                 </a:solidFill>
@@ -7536,7 +7545,7 @@
           </a:p>
           <a:p>
             <a:pPr>
-              <a:defRPr sz="1100">
+              <a:defRPr sz="1100" b="0">
                 <a:solidFill>
                   <a:srgbClr val="172B46"/>
                 </a:solidFill>
@@ -7548,7 +7557,7 @@
           </a:p>
           <a:p>
             <a:pPr>
-              <a:defRPr sz="1100">
+              <a:defRPr sz="1100" b="0">
                 <a:solidFill>
                   <a:srgbClr val="172B46"/>
                 </a:solidFill>
@@ -7638,10 +7647,9 @@
               <a:t>Operational Caveats &amp; System Limitations</a:t>
             </a:r>
           </a:p>
-          <a:p/>
-          <a:p>
-            <a:pPr>
-              <a:defRPr sz="1100">
+          <a:p>
+            <a:pPr>
+              <a:defRPr sz="1100" b="0">
                 <a:solidFill>
                   <a:srgbClr val="172B46"/>
                 </a:solidFill>
@@ -7653,7 +7661,7 @@
           </a:p>
           <a:p>
             <a:pPr>
-              <a:defRPr sz="1100">
+              <a:defRPr sz="1100" b="0">
                 <a:solidFill>
                   <a:srgbClr val="172B46"/>
                 </a:solidFill>
@@ -7665,7 +7673,7 @@
           </a:p>
           <a:p>
             <a:pPr>
-              <a:defRPr sz="1100">
+              <a:defRPr sz="1100" b="0">
                 <a:solidFill>
                   <a:srgbClr val="172B46"/>
                 </a:solidFill>

</xml_diff>